<commit_message>
Update author to Shikhar Verma and improve PPTX styling
</commit_message>
<xml_diff>
--- a/Pitch_Deck.pptx
+++ b/Pitch_Deck.pptx
@@ -3092,7 +3092,7 @@
     <p:bg>
       <p:bgPr>
         <a:solidFill>
-          <a:srgbClr val="0F0F14"/>
+          <a:srgbClr val="1E1E23"/>
         </a:solidFill>
         <a:effectLst/>
       </p:bgPr>
@@ -3120,7 +3120,7 @@
           <a:lstStyle/>
           <a:p>
             <a:pPr>
-              <a:defRPr b="1">
+              <a:defRPr b="1" sz="4400">
                 <a:solidFill>
                   <a:srgbClr val="FF4B4B"/>
                 </a:solidFill>
@@ -3148,9 +3148,9 @@
           <a:lstStyle/>
           <a:p>
             <a:pPr>
-              <a:defRPr>
+              <a:defRPr sz="2400">
                 <a:solidFill>
-                  <a:srgbClr val="FFFFFF"/>
+                  <a:srgbClr val="E6E6E6"/>
                 </a:solidFill>
               </a:defRPr>
             </a:pPr>
@@ -3161,8 +3161,51 @@
           <a:p/>
           <a:p>
             <a:r>
-              <a:t>Prepared by the Data Science Team</a:t>
-            </a:r>
+              <a:t>Prepared by Shikhar Verma</a:t>
+            </a:r>
+          </a:p>
+        </p:txBody>
+      </p:sp>
+      <p:sp>
+        <p:nvSpPr>
+          <p:cNvPr id="4" name="Rectangle 3"/>
+          <p:cNvSpPr/>
+          <p:nvPr/>
+        </p:nvSpPr>
+        <p:spPr>
+          <a:xfrm>
+            <a:off x="0" y="0"/>
+            <a:ext cx="9144000" cy="137160"/>
+          </a:xfrm>
+          <a:prstGeom prst="rect">
+            <a:avLst/>
+          </a:prstGeom>
+          <a:solidFill>
+            <a:srgbClr val="FF4B4B"/>
+          </a:solidFill>
+          <a:ln>
+            <a:noFill/>
+          </a:ln>
+        </p:spPr>
+        <p:style>
+          <a:lnRef idx="1">
+            <a:schemeClr val="accent1"/>
+          </a:lnRef>
+          <a:fillRef idx="3">
+            <a:schemeClr val="accent1"/>
+          </a:fillRef>
+          <a:effectRef idx="2">
+            <a:schemeClr val="accent1"/>
+          </a:effectRef>
+          <a:fontRef idx="minor">
+            <a:schemeClr val="lt1"/>
+          </a:fontRef>
+        </p:style>
+        <p:txBody>
+          <a:bodyPr rtlCol="0" anchor="ctr"/>
+          <a:lstStyle/>
+          <a:p>
+            <a:pPr algn="ctr"/>
           </a:p>
         </p:txBody>
       </p:sp>
@@ -3180,7 +3223,7 @@
     <p:bg>
       <p:bgPr>
         <a:solidFill>
-          <a:srgbClr val="0F0F14"/>
+          <a:srgbClr val="1E1E23"/>
         </a:solidFill>
         <a:effectLst/>
       </p:bgPr>
@@ -3208,7 +3251,7 @@
           <a:lstStyle/>
           <a:p>
             <a:pPr>
-              <a:defRPr>
+              <a:defRPr b="1" sz="3600">
                 <a:solidFill>
                   <a:srgbClr val="FF4B4B"/>
                 </a:solidFill>
@@ -3236,36 +3279,118 @@
           <a:lstStyle/>
           <a:p>
             <a:pPr>
-              <a:defRPr sz="2400">
+              <a:spcAft>
+                <a:spcPts val="1400"/>
+              </a:spcAft>
+              <a:defRPr sz="2200">
                 <a:solidFill>
-                  <a:srgbClr val="FFFFFF"/>
+                  <a:srgbClr val="E6E6E6"/>
                 </a:solidFill>
               </a:defRPr>
             </a:pPr>
             <a:r>
-              <a:t>Delhivery uses OSRM (shortest path) to estimate delivery times. However, real-world logistics is messy. Facility dwell times, node congestion, and route profiles cause actual delivery times to deviate significantly.</a:t>
+              <a:t>• Delhivery uses OSRM (shortest path) to estimate delivery times.</a:t>
             </a:r>
           </a:p>
           <a:p>
             <a:pPr>
-              <a:defRPr sz="2400">
+              <a:spcAft>
+                <a:spcPts val="1400"/>
+              </a:spcAft>
+              <a:defRPr sz="2200">
                 <a:solidFill>
-                  <a:srgbClr val="FFFFFF"/>
+                  <a:srgbClr val="E6E6E6"/>
                 </a:solidFill>
               </a:defRPr>
             </a:pPr>
+            <a:r>
+              <a:t>• Real-world logistics is messy: dwell times, congestion, and operational constraints cause deviations.</a:t>
+            </a:r>
           </a:p>
           <a:p>
             <a:pPr>
-              <a:defRPr sz="2400">
+              <a:spcAft>
+                <a:spcPts val="1400"/>
+              </a:spcAft>
+              <a:defRPr sz="2200">
                 <a:solidFill>
-                  <a:srgbClr val="FFFFFF"/>
+                  <a:srgbClr val="E6E6E6"/>
                 </a:solidFill>
               </a:defRPr>
             </a:pPr>
-            <a:r>
-              <a:t>The Result: A 95%+ SLA Breach Rate on specific chronic routes, leading to unhappy customers and broken capacity planning.</a:t>
-            </a:r>
+          </a:p>
+          <a:p>
+            <a:pPr>
+              <a:spcAft>
+                <a:spcPts val="1400"/>
+              </a:spcAft>
+              <a:defRPr sz="2200">
+                <a:solidFill>
+                  <a:srgbClr val="E6E6E6"/>
+                </a:solidFill>
+              </a:defRPr>
+            </a:pPr>
+            <a:r>
+              <a:t>The Result:</a:t>
+            </a:r>
+          </a:p>
+          <a:p>
+            <a:pPr>
+              <a:spcAft>
+                <a:spcPts val="1400"/>
+              </a:spcAft>
+              <a:defRPr sz="2200">
+                <a:solidFill>
+                  <a:srgbClr val="E6E6E6"/>
+                </a:solidFill>
+              </a:defRPr>
+            </a:pPr>
+            <a:r>
+              <a:t>A 95%+ SLA Breach Rate on chronic routes, breaking downstream capacity planning.</a:t>
+            </a:r>
+          </a:p>
+        </p:txBody>
+      </p:sp>
+      <p:sp>
+        <p:nvSpPr>
+          <p:cNvPr id="4" name="Rectangle 3"/>
+          <p:cNvSpPr/>
+          <p:nvPr/>
+        </p:nvSpPr>
+        <p:spPr>
+          <a:xfrm>
+            <a:off x="0" y="0"/>
+            <a:ext cx="9144000" cy="137160"/>
+          </a:xfrm>
+          <a:prstGeom prst="rect">
+            <a:avLst/>
+          </a:prstGeom>
+          <a:solidFill>
+            <a:srgbClr val="FF4B4B"/>
+          </a:solidFill>
+          <a:ln>
+            <a:noFill/>
+          </a:ln>
+        </p:spPr>
+        <p:style>
+          <a:lnRef idx="1">
+            <a:schemeClr val="accent1"/>
+          </a:lnRef>
+          <a:fillRef idx="3">
+            <a:schemeClr val="accent1"/>
+          </a:fillRef>
+          <a:effectRef idx="2">
+            <a:schemeClr val="accent1"/>
+          </a:effectRef>
+          <a:fontRef idx="minor">
+            <a:schemeClr val="lt1"/>
+          </a:fontRef>
+        </p:style>
+        <p:txBody>
+          <a:bodyPr rtlCol="0" anchor="ctr"/>
+          <a:lstStyle/>
+          <a:p>
+            <a:pPr algn="ctr"/>
           </a:p>
         </p:txBody>
       </p:sp>
@@ -3283,7 +3408,7 @@
     <p:bg>
       <p:bgPr>
         <a:solidFill>
-          <a:srgbClr val="0F0F14"/>
+          <a:srgbClr val="1E1E23"/>
         </a:solidFill>
         <a:effectLst/>
       </p:bgPr>
@@ -3311,7 +3436,7 @@
           <a:lstStyle/>
           <a:p>
             <a:pPr>
-              <a:defRPr>
+              <a:defRPr b="1" sz="3600">
                 <a:solidFill>
                   <a:srgbClr val="FF4B4B"/>
                 </a:solidFill>
@@ -3339,60 +3464,133 @@
           <a:lstStyle/>
           <a:p>
             <a:pPr>
-              <a:defRPr sz="2800">
+              <a:spcAft>
+                <a:spcPts val="1400"/>
+              </a:spcAft>
+              <a:defRPr sz="2200">
                 <a:solidFill>
-                  <a:srgbClr val="FFFFFF"/>
+                  <a:srgbClr val="E6E6E6"/>
                 </a:solidFill>
               </a:defRPr>
             </a:pPr>
             <a:r>
-              <a:t>We modeled the logistics network not as isolated trips, but as a living Directed Graph.</a:t>
+              <a:t>We modeled the logistics network not as isolated trips, but as a living Directed Graph to find structural flaws.</a:t>
             </a:r>
           </a:p>
           <a:p>
             <a:pPr>
-              <a:defRPr sz="2800">
+              <a:spcAft>
+                <a:spcPts val="1400"/>
+              </a:spcAft>
+              <a:defRPr sz="2200">
                 <a:solidFill>
-                  <a:srgbClr val="FFFFFF"/>
+                  <a:srgbClr val="E6E6E6"/>
                 </a:solidFill>
               </a:defRPr>
             </a:pPr>
           </a:p>
           <a:p>
             <a:pPr>
-              <a:defRPr sz="2800">
+              <a:spcAft>
+                <a:spcPts val="1400"/>
+              </a:spcAft>
+              <a:defRPr sz="2200">
                 <a:solidFill>
-                  <a:srgbClr val="FFFFFF"/>
+                  <a:srgbClr val="E6E6E6"/>
                 </a:solidFill>
               </a:defRPr>
             </a:pPr>
             <a:r>
-              <a:t>• 1,657 Facilities (Nodes)</a:t>
+              <a:t>Network Scale:</a:t>
             </a:r>
           </a:p>
           <a:p>
             <a:pPr>
-              <a:defRPr sz="2800">
+              <a:spcAft>
+                <a:spcPts val="1400"/>
+              </a:spcAft>
+              <a:defRPr sz="2200">
                 <a:solidFill>
-                  <a:srgbClr val="FFFFFF"/>
+                  <a:srgbClr val="E6E6E6"/>
                 </a:solidFill>
               </a:defRPr>
             </a:pPr>
             <a:r>
-              <a:t>• 2,783 Corridors (Edges)</a:t>
+              <a:t>• 1,657 Connected Facilities (Nodes)</a:t>
             </a:r>
           </a:p>
           <a:p>
             <a:pPr>
-              <a:defRPr sz="2800">
+              <a:spcAft>
+                <a:spcPts val="1400"/>
+              </a:spcAft>
+              <a:defRPr sz="2200">
                 <a:solidFill>
-                  <a:srgbClr val="FFFFFF"/>
+                  <a:srgbClr val="E6E6E6"/>
                 </a:solidFill>
               </a:defRPr>
             </a:pPr>
             <a:r>
-              <a:t>• 2,617 Chronic Delay Corridors</a:t>
-            </a:r>
+              <a:t>• 2,783 Logistics Corridors (Edges)</a:t>
+            </a:r>
+          </a:p>
+          <a:p>
+            <a:pPr>
+              <a:spcAft>
+                <a:spcPts val="1400"/>
+              </a:spcAft>
+              <a:defRPr sz="2200">
+                <a:solidFill>
+                  <a:srgbClr val="E6E6E6"/>
+                </a:solidFill>
+              </a:defRPr>
+            </a:pPr>
+            <a:r>
+              <a:t>• 2,617 Chronic Delay Corridors Identified</a:t>
+            </a:r>
+          </a:p>
+        </p:txBody>
+      </p:sp>
+      <p:sp>
+        <p:nvSpPr>
+          <p:cNvPr id="4" name="Rectangle 3"/>
+          <p:cNvSpPr/>
+          <p:nvPr/>
+        </p:nvSpPr>
+        <p:spPr>
+          <a:xfrm>
+            <a:off x="0" y="0"/>
+            <a:ext cx="9144000" cy="137160"/>
+          </a:xfrm>
+          <a:prstGeom prst="rect">
+            <a:avLst/>
+          </a:prstGeom>
+          <a:solidFill>
+            <a:srgbClr val="FF4B4B"/>
+          </a:solidFill>
+          <a:ln>
+            <a:noFill/>
+          </a:ln>
+        </p:spPr>
+        <p:style>
+          <a:lnRef idx="1">
+            <a:schemeClr val="accent1"/>
+          </a:lnRef>
+          <a:fillRef idx="3">
+            <a:schemeClr val="accent1"/>
+          </a:fillRef>
+          <a:effectRef idx="2">
+            <a:schemeClr val="accent1"/>
+          </a:effectRef>
+          <a:fontRef idx="minor">
+            <a:schemeClr val="lt1"/>
+          </a:fontRef>
+        </p:style>
+        <p:txBody>
+          <a:bodyPr rtlCol="0" anchor="ctr"/>
+          <a:lstStyle/>
+          <a:p>
+            <a:pPr algn="ctr"/>
           </a:p>
         </p:txBody>
       </p:sp>
@@ -3410,7 +3608,7 @@
     <p:bg>
       <p:bgPr>
         <a:solidFill>
-          <a:srgbClr val="0F0F14"/>
+          <a:srgbClr val="1E1E23"/>
         </a:solidFill>
         <a:effectLst/>
       </p:bgPr>
@@ -3438,7 +3636,7 @@
           <a:lstStyle/>
           <a:p>
             <a:pPr>
-              <a:defRPr>
+              <a:defRPr b="1" sz="3600">
                 <a:solidFill>
                   <a:srgbClr val="FF4B4B"/>
                 </a:solidFill>
@@ -3450,9 +3648,52 @@
           </a:p>
         </p:txBody>
       </p:sp>
+      <p:sp>
+        <p:nvSpPr>
+          <p:cNvPr id="3" name="Rectangle 2"/>
+          <p:cNvSpPr/>
+          <p:nvPr/>
+        </p:nvSpPr>
+        <p:spPr>
+          <a:xfrm>
+            <a:off x="0" y="0"/>
+            <a:ext cx="9144000" cy="137160"/>
+          </a:xfrm>
+          <a:prstGeom prst="rect">
+            <a:avLst/>
+          </a:prstGeom>
+          <a:solidFill>
+            <a:srgbClr val="FF4B4B"/>
+          </a:solidFill>
+          <a:ln>
+            <a:noFill/>
+          </a:ln>
+        </p:spPr>
+        <p:style>
+          <a:lnRef idx="1">
+            <a:schemeClr val="accent1"/>
+          </a:lnRef>
+          <a:fillRef idx="3">
+            <a:schemeClr val="accent1"/>
+          </a:fillRef>
+          <a:effectRef idx="2">
+            <a:schemeClr val="accent1"/>
+          </a:effectRef>
+          <a:fontRef idx="minor">
+            <a:schemeClr val="lt1"/>
+          </a:fontRef>
+        </p:style>
+        <p:txBody>
+          <a:bodyPr rtlCol="0" anchor="ctr"/>
+          <a:lstStyle/>
+          <a:p>
+            <a:pPr algn="ctr"/>
+          </a:p>
+        </p:txBody>
+      </p:sp>
       <p:pic>
         <p:nvPicPr>
-          <p:cNvPr id="3" name="Picture 2" descr="network_bottleneck.png"/>
+          <p:cNvPr id="4" name="Picture 3" descr="network_bottleneck.png"/>
           <p:cNvPicPr>
             <a:picLocks noChangeAspect="1"/>
           </p:cNvPicPr>
@@ -3467,7 +3708,7 @@
         <p:spPr>
           <a:xfrm>
             <a:off x="1371600" y="1371600"/>
-            <a:ext cx="6400800" cy="5736785"/>
+            <a:ext cx="5611315" cy="5029200"/>
           </a:xfrm>
           <a:prstGeom prst="rect">
             <a:avLst/>
@@ -3488,7 +3729,7 @@
     <p:bg>
       <p:bgPr>
         <a:solidFill>
-          <a:srgbClr val="0F0F14"/>
+          <a:srgbClr val="1E1E23"/>
         </a:solidFill>
         <a:effectLst/>
       </p:bgPr>
@@ -3516,7 +3757,7 @@
           <a:lstStyle/>
           <a:p>
             <a:pPr>
-              <a:defRPr>
+              <a:defRPr b="1" sz="3600">
                 <a:solidFill>
                   <a:srgbClr val="FF4B4B"/>
                 </a:solidFill>
@@ -3528,9 +3769,52 @@
           </a:p>
         </p:txBody>
       </p:sp>
+      <p:sp>
+        <p:nvSpPr>
+          <p:cNvPr id="3" name="Rectangle 2"/>
+          <p:cNvSpPr/>
+          <p:nvPr/>
+        </p:nvSpPr>
+        <p:spPr>
+          <a:xfrm>
+            <a:off x="0" y="0"/>
+            <a:ext cx="9144000" cy="137160"/>
+          </a:xfrm>
+          <a:prstGeom prst="rect">
+            <a:avLst/>
+          </a:prstGeom>
+          <a:solidFill>
+            <a:srgbClr val="FF4B4B"/>
+          </a:solidFill>
+          <a:ln>
+            <a:noFill/>
+          </a:ln>
+        </p:spPr>
+        <p:style>
+          <a:lnRef idx="1">
+            <a:schemeClr val="accent1"/>
+          </a:lnRef>
+          <a:fillRef idx="3">
+            <a:schemeClr val="accent1"/>
+          </a:fillRef>
+          <a:effectRef idx="2">
+            <a:schemeClr val="accent1"/>
+          </a:effectRef>
+          <a:fontRef idx="minor">
+            <a:schemeClr val="lt1"/>
+          </a:fontRef>
+        </p:style>
+        <p:txBody>
+          <a:bodyPr rtlCol="0" anchor="ctr"/>
+          <a:lstStyle/>
+          <a:p>
+            <a:pPr algn="ctr"/>
+          </a:p>
+        </p:txBody>
+      </p:sp>
       <p:pic>
         <p:nvPicPr>
-          <p:cNvPr id="3" name="Picture 2" descr="top_hubs.png"/>
+          <p:cNvPr id="4" name="Picture 3" descr="top_hubs.png"/>
           <p:cNvPicPr>
             <a:picLocks noChangeAspect="1"/>
           </p:cNvPicPr>
@@ -3544,8 +3828,8 @@
         </p:blipFill>
         <p:spPr>
           <a:xfrm>
-            <a:off x="914400" y="1371600"/>
-            <a:ext cx="7315200" cy="3880923"/>
+            <a:off x="457200" y="1828800"/>
+            <a:ext cx="8229600" cy="4366039"/>
           </a:xfrm>
           <a:prstGeom prst="rect">
             <a:avLst/>
@@ -3566,7 +3850,7 @@
     <p:bg>
       <p:bgPr>
         <a:solidFill>
-          <a:srgbClr val="0F0F14"/>
+          <a:srgbClr val="1E1E23"/>
         </a:solidFill>
         <a:effectLst/>
       </p:bgPr>
@@ -3594,7 +3878,7 @@
           <a:lstStyle/>
           <a:p>
             <a:pPr>
-              <a:defRPr>
+              <a:defRPr b="1" sz="3600">
                 <a:solidFill>
                   <a:srgbClr val="FF4B4B"/>
                 </a:solidFill>
@@ -3606,9 +3890,52 @@
           </a:p>
         </p:txBody>
       </p:sp>
+      <p:sp>
+        <p:nvSpPr>
+          <p:cNvPr id="3" name="Rectangle 2"/>
+          <p:cNvSpPr/>
+          <p:nvPr/>
+        </p:nvSpPr>
+        <p:spPr>
+          <a:xfrm>
+            <a:off x="0" y="0"/>
+            <a:ext cx="9144000" cy="137160"/>
+          </a:xfrm>
+          <a:prstGeom prst="rect">
+            <a:avLst/>
+          </a:prstGeom>
+          <a:solidFill>
+            <a:srgbClr val="FF4B4B"/>
+          </a:solidFill>
+          <a:ln>
+            <a:noFill/>
+          </a:ln>
+        </p:spPr>
+        <p:style>
+          <a:lnRef idx="1">
+            <a:schemeClr val="accent1"/>
+          </a:lnRef>
+          <a:fillRef idx="3">
+            <a:schemeClr val="accent1"/>
+          </a:fillRef>
+          <a:effectRef idx="2">
+            <a:schemeClr val="accent1"/>
+          </a:effectRef>
+          <a:fontRef idx="minor">
+            <a:schemeClr val="lt1"/>
+          </a:fontRef>
+        </p:style>
+        <p:txBody>
+          <a:bodyPr rtlCol="0" anchor="ctr"/>
+          <a:lstStyle/>
+          <a:p>
+            <a:pPr algn="ctr"/>
+          </a:p>
+        </p:txBody>
+      </p:sp>
       <p:pic>
         <p:nvPicPr>
-          <p:cNvPr id="3" name="Picture 2" descr="model_comparison.png"/>
+          <p:cNvPr id="4" name="Picture 3" descr="model_comparison.png"/>
           <p:cNvPicPr>
             <a:picLocks noChangeAspect="1"/>
           </p:cNvPicPr>
@@ -3622,8 +3949,8 @@
         </p:blipFill>
         <p:spPr>
           <a:xfrm>
-            <a:off x="914400" y="1371600"/>
-            <a:ext cx="7315200" cy="3469108"/>
+            <a:off x="457200" y="1371600"/>
+            <a:ext cx="8229600" cy="3902746"/>
           </a:xfrm>
           <a:prstGeom prst="rect">
             <a:avLst/>
@@ -3632,13 +3959,13 @@
       </p:pic>
       <p:sp>
         <p:nvSpPr>
-          <p:cNvPr id="4" name="TextBox 3"/>
+          <p:cNvPr id="5" name="TextBox 4"/>
           <p:cNvSpPr txBox="1"/>
           <p:nvPr/>
         </p:nvSpPr>
         <p:spPr>
           <a:xfrm>
-            <a:off x="914400" y="5943600"/>
+            <a:off x="914400" y="5760720"/>
             <a:ext cx="7315200" cy="914400"/>
           </a:xfrm>
           <a:prstGeom prst="rect">
@@ -3652,15 +3979,15 @@
           </a:bodyPr>
           <a:lstStyle/>
           <a:p>
-            <a:pPr>
-              <a:defRPr b="1" sz="2400">
+            <a:pPr algn="ctr">
+              <a:defRPr b="1" sz="2200">
                 <a:solidFill>
                   <a:srgbClr val="4CAF50"/>
                 </a:solidFill>
               </a:defRPr>
             </a:pPr>
             <a:r>
-              <a:t>Result: +8.57% improvement in 15%-Accuracy</a:t>
+              <a:t>Result: +8.57% improvement in 15%-Accuracy over OSRM Baseline</a:t>
             </a:r>
           </a:p>
         </p:txBody>
@@ -3679,7 +4006,7 @@
     <p:bg>
       <p:bgPr>
         <a:solidFill>
-          <a:srgbClr val="0F0F14"/>
+          <a:srgbClr val="1E1E23"/>
         </a:solidFill>
         <a:effectLst/>
       </p:bgPr>
@@ -3707,7 +4034,7 @@
           <a:lstStyle/>
           <a:p>
             <a:pPr>
-              <a:defRPr>
+              <a:defRPr b="1" sz="3600">
                 <a:solidFill>
                   <a:srgbClr val="FF4B4B"/>
                 </a:solidFill>
@@ -3719,9 +4046,52 @@
           </a:p>
         </p:txBody>
       </p:sp>
+      <p:sp>
+        <p:nvSpPr>
+          <p:cNvPr id="3" name="Rectangle 2"/>
+          <p:cNvSpPr/>
+          <p:nvPr/>
+        </p:nvSpPr>
+        <p:spPr>
+          <a:xfrm>
+            <a:off x="0" y="0"/>
+            <a:ext cx="9144000" cy="137160"/>
+          </a:xfrm>
+          <a:prstGeom prst="rect">
+            <a:avLst/>
+          </a:prstGeom>
+          <a:solidFill>
+            <a:srgbClr val="FF4B4B"/>
+          </a:solidFill>
+          <a:ln>
+            <a:noFill/>
+          </a:ln>
+        </p:spPr>
+        <p:style>
+          <a:lnRef idx="1">
+            <a:schemeClr val="accent1"/>
+          </a:lnRef>
+          <a:fillRef idx="3">
+            <a:schemeClr val="accent1"/>
+          </a:fillRef>
+          <a:effectRef idx="2">
+            <a:schemeClr val="accent1"/>
+          </a:effectRef>
+          <a:fontRef idx="minor">
+            <a:schemeClr val="lt1"/>
+          </a:fontRef>
+        </p:style>
+        <p:txBody>
+          <a:bodyPr rtlCol="0" anchor="ctr"/>
+          <a:lstStyle/>
+          <a:p>
+            <a:pPr algn="ctr"/>
+          </a:p>
+        </p:txBody>
+      </p:sp>
       <p:pic>
         <p:nvPicPr>
-          <p:cNvPr id="3" name="Picture 2" descr="ftl_decision_boundary.png"/>
+          <p:cNvPr id="4" name="Picture 3" descr="ftl_decision_boundary.png"/>
           <p:cNvPicPr>
             <a:picLocks noChangeAspect="1"/>
           </p:cNvPicPr>
@@ -3736,7 +4106,7 @@
         <p:spPr>
           <a:xfrm>
             <a:off x="1371600" y="1371600"/>
-            <a:ext cx="6400800" cy="4343211"/>
+            <a:ext cx="7411776" cy="5029200"/>
           </a:xfrm>
           <a:prstGeom prst="rect">
             <a:avLst/>
@@ -3757,7 +4127,7 @@
     <p:bg>
       <p:bgPr>
         <a:solidFill>
-          <a:srgbClr val="0F0F14"/>
+          <a:srgbClr val="1E1E23"/>
         </a:solidFill>
         <a:effectLst/>
       </p:bgPr>
@@ -3785,7 +4155,7 @@
           <a:lstStyle/>
           <a:p>
             <a:pPr>
-              <a:defRPr>
+              <a:defRPr b="1" sz="3600">
                 <a:solidFill>
                   <a:srgbClr val="FF4B4B"/>
                 </a:solidFill>
@@ -3813,39 +4183,91 @@
           <a:lstStyle/>
           <a:p>
             <a:pPr>
+              <a:spcAft>
+                <a:spcPts val="1400"/>
+              </a:spcAft>
               <a:defRPr sz="2200">
                 <a:solidFill>
-                  <a:srgbClr val="FFFFFF"/>
+                  <a:srgbClr val="E6E6E6"/>
                 </a:solidFill>
               </a:defRPr>
             </a:pPr>
             <a:r>
-              <a:t>• Infrastructure: Upgrade capacity at Gurgaon Bilaspur HB and Bangalore Nelmngla. These single points of failure create massive ripple effects.</a:t>
+              <a:t>• Infrastructure Interventions: Upgrade capacity at Gurgaon Bilaspur HB and Bangalore Nelmngla. These are single points of failure causing massive ripple effects.</a:t>
             </a:r>
           </a:p>
           <a:p>
             <a:pPr>
+              <a:spcAft>
+                <a:spcPts val="1400"/>
+              </a:spcAft>
               <a:defRPr sz="2200">
                 <a:solidFill>
-                  <a:srgbClr val="FFFFFF"/>
+                  <a:srgbClr val="E6E6E6"/>
                 </a:solidFill>
               </a:defRPr>
             </a:pPr>
             <a:r>
-              <a:t>• Financial Impact: Upgrading the top 3 bottleneck hubs to the network median delay ratio recovers an estimated ₹1.05 Crore in revenue at risk.</a:t>
+              <a:t>• Financial Impact: Upgrading the top 3 bottleneck hubs to the network median delay recovers an estimated ₹1.05 Crore in revenue at risk.</a:t>
             </a:r>
           </a:p>
           <a:p>
             <a:pPr>
+              <a:spcAft>
+                <a:spcPts val="1400"/>
+              </a:spcAft>
               <a:defRPr sz="2200">
                 <a:solidFill>
-                  <a:srgbClr val="FFFFFF"/>
+                  <a:srgbClr val="E6E6E6"/>
                 </a:solidFill>
               </a:defRPr>
             </a:pPr>
             <a:r>
-              <a:t>• Deployment: Integrate the Graph-Enhanced XGBoost model into the customer-facing tracking app to drastically improve transparency.</a:t>
-            </a:r>
+              <a:t>• Product Deployment: Integrate the Graph-Enhanced XGBoost model into the customer-facing tracking app to drastically improve consumer transparency.</a:t>
+            </a:r>
+          </a:p>
+        </p:txBody>
+      </p:sp>
+      <p:sp>
+        <p:nvSpPr>
+          <p:cNvPr id="4" name="Rectangle 3"/>
+          <p:cNvSpPr/>
+          <p:nvPr/>
+        </p:nvSpPr>
+        <p:spPr>
+          <a:xfrm>
+            <a:off x="0" y="0"/>
+            <a:ext cx="9144000" cy="137160"/>
+          </a:xfrm>
+          <a:prstGeom prst="rect">
+            <a:avLst/>
+          </a:prstGeom>
+          <a:solidFill>
+            <a:srgbClr val="FF4B4B"/>
+          </a:solidFill>
+          <a:ln>
+            <a:noFill/>
+          </a:ln>
+        </p:spPr>
+        <p:style>
+          <a:lnRef idx="1">
+            <a:schemeClr val="accent1"/>
+          </a:lnRef>
+          <a:fillRef idx="3">
+            <a:schemeClr val="accent1"/>
+          </a:fillRef>
+          <a:effectRef idx="2">
+            <a:schemeClr val="accent1"/>
+          </a:effectRef>
+          <a:fontRef idx="minor">
+            <a:schemeClr val="lt1"/>
+          </a:fontRef>
+        </p:style>
+        <p:txBody>
+          <a:bodyPr rtlCol="0" anchor="ctr"/>
+          <a:lstStyle/>
+          <a:p>
+            <a:pPr algn="ctr"/>
           </a:p>
         </p:txBody>
       </p:sp>
@@ -3863,7 +4285,7 @@
     <p:bg>
       <p:bgPr>
         <a:solidFill>
-          <a:srgbClr val="0F0F14"/>
+          <a:srgbClr val="1E1E23"/>
         </a:solidFill>
         <a:effectLst/>
       </p:bgPr>
@@ -3891,7 +4313,7 @@
           <a:lstStyle/>
           <a:p>
             <a:pPr>
-              <a:defRPr>
+              <a:defRPr sz="5400">
                 <a:solidFill>
                   <a:srgbClr val="FF4B4B"/>
                 </a:solidFill>
@@ -3919,20 +4341,63 @@
           <a:lstStyle/>
           <a:p>
             <a:pPr>
-              <a:defRPr>
+              <a:defRPr sz="2400">
                 <a:solidFill>
-                  <a:srgbClr val="FFFFFF"/>
+                  <a:srgbClr val="E6E6E6"/>
                 </a:solidFill>
               </a:defRPr>
             </a:pPr>
             <a:r>
-              <a:t>Explore the Live Interactive Dashboard:</a:t>
+              <a:t>Explore the Live Dashboard:</a:t>
             </a:r>
           </a:p>
           <a:p>
             <a:r>
               <a:t>delhivery-graph-intelligence-system.streamlit.app</a:t>
             </a:r>
+          </a:p>
+        </p:txBody>
+      </p:sp>
+      <p:sp>
+        <p:nvSpPr>
+          <p:cNvPr id="4" name="Rectangle 3"/>
+          <p:cNvSpPr/>
+          <p:nvPr/>
+        </p:nvSpPr>
+        <p:spPr>
+          <a:xfrm>
+            <a:off x="0" y="0"/>
+            <a:ext cx="9144000" cy="137160"/>
+          </a:xfrm>
+          <a:prstGeom prst="rect">
+            <a:avLst/>
+          </a:prstGeom>
+          <a:solidFill>
+            <a:srgbClr val="FF4B4B"/>
+          </a:solidFill>
+          <a:ln>
+            <a:noFill/>
+          </a:ln>
+        </p:spPr>
+        <p:style>
+          <a:lnRef idx="1">
+            <a:schemeClr val="accent1"/>
+          </a:lnRef>
+          <a:fillRef idx="3">
+            <a:schemeClr val="accent1"/>
+          </a:fillRef>
+          <a:effectRef idx="2">
+            <a:schemeClr val="accent1"/>
+          </a:effectRef>
+          <a:fontRef idx="minor">
+            <a:schemeClr val="lt1"/>
+          </a:fontRef>
+        </p:style>
+        <p:txBody>
+          <a:bodyPr rtlCol="0" anchor="ctr"/>
+          <a:lstStyle/>
+          <a:p>
+            <a:pPr algn="ctr"/>
           </a:p>
         </p:txBody>
       </p:sp>

</xml_diff>

<commit_message>
Enhance PPTX with minimalist corporate design and AI-generated vector doodles
</commit_message>
<xml_diff>
--- a/Pitch_Deck.pptx
+++ b/Pitch_Deck.pptx
@@ -3092,7 +3092,7 @@
     <p:bg>
       <p:bgPr>
         <a:solidFill>
-          <a:srgbClr val="1E1E23"/>
+          <a:srgbClr val="F5F7FA"/>
         </a:solidFill>
         <a:effectLst/>
       </p:bgPr>
@@ -3120,9 +3120,9 @@
           <a:lstStyle/>
           <a:p>
             <a:pPr>
-              <a:defRPr b="1" sz="4400">
+              <a:defRPr b="1" sz="4800">
                 <a:solidFill>
-                  <a:srgbClr val="FF4B4B"/>
+                  <a:srgbClr val="1E3C72"/>
                 </a:solidFill>
               </a:defRPr>
             </a:pPr>
@@ -3148,9 +3148,9 @@
           <a:lstStyle/>
           <a:p>
             <a:pPr>
-              <a:defRPr sz="2400">
+              <a:defRPr sz="2200">
                 <a:solidFill>
-                  <a:srgbClr val="E6E6E6"/>
+                  <a:srgbClr val="64696E"/>
                 </a:solidFill>
               </a:defRPr>
             </a:pPr>
@@ -3175,13 +3175,13 @@
         <p:spPr>
           <a:xfrm>
             <a:off x="0" y="0"/>
-            <a:ext cx="9144000" cy="137160"/>
+            <a:ext cx="9144000" cy="182880"/>
           </a:xfrm>
           <a:prstGeom prst="rect">
             <a:avLst/>
           </a:prstGeom>
           <a:solidFill>
-            <a:srgbClr val="FF4B4B"/>
+            <a:srgbClr val="1E3C72"/>
           </a:solidFill>
           <a:ln>
             <a:noFill/>
@@ -3209,6 +3209,30 @@
           </a:p>
         </p:txBody>
       </p:sp>
+      <p:pic>
+        <p:nvPicPr>
+          <p:cNvPr id="5" name="Picture 4" descr="doodle_truck.png"/>
+          <p:cNvPicPr>
+            <a:picLocks noChangeAspect="1"/>
+          </p:cNvPicPr>
+          <p:nvPr/>
+        </p:nvPicPr>
+        <p:blipFill>
+          <a:blip r:embed="rId2"/>
+          <a:stretch>
+            <a:fillRect/>
+          </a:stretch>
+        </p:blipFill>
+        <p:spPr>
+          <a:xfrm>
+            <a:off x="3200400" y="4114800"/>
+            <a:ext cx="2286000" cy="2286000"/>
+          </a:xfrm>
+          <a:prstGeom prst="rect">
+            <a:avLst/>
+          </a:prstGeom>
+        </p:spPr>
+      </p:pic>
     </p:spTree>
   </p:cSld>
   <p:clrMapOvr>
@@ -3223,7 +3247,7 @@
     <p:bg>
       <p:bgPr>
         <a:solidFill>
-          <a:srgbClr val="1E1E23"/>
+          <a:srgbClr val="F5F7FA"/>
         </a:solidFill>
         <a:effectLst/>
       </p:bgPr>
@@ -3253,7 +3277,7 @@
             <a:pPr>
               <a:defRPr b="1" sz="3600">
                 <a:solidFill>
-                  <a:srgbClr val="FF4B4B"/>
+                  <a:srgbClr val="1E3C72"/>
                 </a:solidFill>
               </a:defRPr>
             </a:pPr>
@@ -3265,108 +3289,20 @@
       </p:sp>
       <p:sp>
         <p:nvSpPr>
-          <p:cNvPr id="3" name="Content Placeholder 2"/>
-          <p:cNvSpPr>
-            <a:spLocks noGrp="1"/>
-          </p:cNvSpPr>
-          <p:nvPr>
-            <p:ph idx="1"/>
-          </p:nvPr>
-        </p:nvSpPr>
-        <p:spPr/>
-        <p:txBody>
-          <a:bodyPr/>
-          <a:lstStyle/>
-          <a:p>
-            <a:pPr>
-              <a:spcAft>
-                <a:spcPts val="1400"/>
-              </a:spcAft>
-              <a:defRPr sz="2200">
-                <a:solidFill>
-                  <a:srgbClr val="E6E6E6"/>
-                </a:solidFill>
-              </a:defRPr>
-            </a:pPr>
-            <a:r>
-              <a:t>• Delhivery uses OSRM (shortest path) to estimate delivery times.</a:t>
-            </a:r>
-          </a:p>
-          <a:p>
-            <a:pPr>
-              <a:spcAft>
-                <a:spcPts val="1400"/>
-              </a:spcAft>
-              <a:defRPr sz="2200">
-                <a:solidFill>
-                  <a:srgbClr val="E6E6E6"/>
-                </a:solidFill>
-              </a:defRPr>
-            </a:pPr>
-            <a:r>
-              <a:t>• Real-world logistics is messy: dwell times, congestion, and operational constraints cause deviations.</a:t>
-            </a:r>
-          </a:p>
-          <a:p>
-            <a:pPr>
-              <a:spcAft>
-                <a:spcPts val="1400"/>
-              </a:spcAft>
-              <a:defRPr sz="2200">
-                <a:solidFill>
-                  <a:srgbClr val="E6E6E6"/>
-                </a:solidFill>
-              </a:defRPr>
-            </a:pPr>
-          </a:p>
-          <a:p>
-            <a:pPr>
-              <a:spcAft>
-                <a:spcPts val="1400"/>
-              </a:spcAft>
-              <a:defRPr sz="2200">
-                <a:solidFill>
-                  <a:srgbClr val="E6E6E6"/>
-                </a:solidFill>
-              </a:defRPr>
-            </a:pPr>
-            <a:r>
-              <a:t>The Result:</a:t>
-            </a:r>
-          </a:p>
-          <a:p>
-            <a:pPr>
-              <a:spcAft>
-                <a:spcPts val="1400"/>
-              </a:spcAft>
-              <a:defRPr sz="2200">
-                <a:solidFill>
-                  <a:srgbClr val="E6E6E6"/>
-                </a:solidFill>
-              </a:defRPr>
-            </a:pPr>
-            <a:r>
-              <a:t>A 95%+ SLA Breach Rate on chronic routes, breaking downstream capacity planning.</a:t>
-            </a:r>
-          </a:p>
-        </p:txBody>
-      </p:sp>
-      <p:sp>
-        <p:nvSpPr>
-          <p:cNvPr id="4" name="Rectangle 3"/>
+          <p:cNvPr id="3" name="Rectangle 2"/>
           <p:cNvSpPr/>
           <p:nvPr/>
         </p:nvSpPr>
         <p:spPr>
           <a:xfrm>
             <a:off x="0" y="0"/>
-            <a:ext cx="9144000" cy="137160"/>
+            <a:ext cx="9144000" cy="182880"/>
           </a:xfrm>
           <a:prstGeom prst="rect">
             <a:avLst/>
           </a:prstGeom>
           <a:solidFill>
-            <a:srgbClr val="FF4B4B"/>
+            <a:srgbClr val="1E3C72"/>
           </a:solidFill>
           <a:ln>
             <a:noFill/>
@@ -3394,6 +3330,125 @@
           </a:p>
         </p:txBody>
       </p:sp>
+      <p:sp>
+        <p:nvSpPr>
+          <p:cNvPr id="4" name="TextBox 3"/>
+          <p:cNvSpPr txBox="1"/>
+          <p:nvPr/>
+        </p:nvSpPr>
+        <p:spPr>
+          <a:xfrm>
+            <a:off x="457200" y="1371600"/>
+            <a:ext cx="4572000" cy="3657600"/>
+          </a:xfrm>
+          <a:prstGeom prst="rect">
+            <a:avLst/>
+          </a:prstGeom>
+          <a:noFill/>
+        </p:spPr>
+        <p:txBody>
+          <a:bodyPr wrap="none">
+            <a:spAutoFit/>
+          </a:bodyPr>
+          <a:lstStyle/>
+          <a:p>
+            <a:pPr>
+              <a:spcAft>
+                <a:spcPts val="1200"/>
+              </a:spcAft>
+              <a:defRPr sz="2000">
+                <a:solidFill>
+                  <a:srgbClr val="282D32"/>
+                </a:solidFill>
+              </a:defRPr>
+            </a:pPr>
+            <a:r>
+              <a:t>• Delhivery uses OSRM (shortest path) to estimate delivery times.</a:t>
+            </a:r>
+          </a:p>
+          <a:p>
+            <a:pPr>
+              <a:spcAft>
+                <a:spcPts val="1200"/>
+              </a:spcAft>
+              <a:defRPr sz="2000">
+                <a:solidFill>
+                  <a:srgbClr val="282D32"/>
+                </a:solidFill>
+              </a:defRPr>
+            </a:pPr>
+            <a:r>
+              <a:t>• Real-world logistics is messy: dwell times, congestion, and operational constraints cause massive deviations.</a:t>
+            </a:r>
+          </a:p>
+          <a:p>
+            <a:pPr>
+              <a:spcAft>
+                <a:spcPts val="1200"/>
+              </a:spcAft>
+              <a:defRPr sz="2000">
+                <a:solidFill>
+                  <a:srgbClr val="282D32"/>
+                </a:solidFill>
+              </a:defRPr>
+            </a:pPr>
+          </a:p>
+          <a:p>
+            <a:pPr>
+              <a:spcAft>
+                <a:spcPts val="1200"/>
+              </a:spcAft>
+              <a:defRPr sz="2000">
+                <a:solidFill>
+                  <a:srgbClr val="282D32"/>
+                </a:solidFill>
+              </a:defRPr>
+            </a:pPr>
+            <a:r>
+              <a:t>The Result:</a:t>
+            </a:r>
+          </a:p>
+          <a:p>
+            <a:pPr>
+              <a:spcAft>
+                <a:spcPts val="1200"/>
+              </a:spcAft>
+              <a:defRPr sz="2000">
+                <a:solidFill>
+                  <a:srgbClr val="282D32"/>
+                </a:solidFill>
+              </a:defRPr>
+            </a:pPr>
+            <a:r>
+              <a:t>A 95%+ SLA Breach Rate on chronic routes, breaking downstream capacity planning.</a:t>
+            </a:r>
+          </a:p>
+        </p:txBody>
+      </p:sp>
+      <p:pic>
+        <p:nvPicPr>
+          <p:cNvPr id="5" name="Picture 4" descr="doodle_bottleneck.png"/>
+          <p:cNvPicPr>
+            <a:picLocks noChangeAspect="1"/>
+          </p:cNvPicPr>
+          <p:nvPr/>
+        </p:nvPicPr>
+        <p:blipFill>
+          <a:blip r:embed="rId2"/>
+          <a:stretch>
+            <a:fillRect/>
+          </a:stretch>
+        </p:blipFill>
+        <p:spPr>
+          <a:xfrm>
+            <a:off x="5029200" y="1371600"/>
+            <a:ext cx="3657600" cy="3657600"/>
+          </a:xfrm>
+          <a:prstGeom prst="rect">
+            <a:avLst/>
+          </a:prstGeom>
+        </p:spPr>
+      </p:pic>
     </p:spTree>
   </p:cSld>
   <p:clrMapOvr>
@@ -3408,7 +3463,7 @@
     <p:bg>
       <p:bgPr>
         <a:solidFill>
-          <a:srgbClr val="1E1E23"/>
+          <a:srgbClr val="F5F7FA"/>
         </a:solidFill>
         <a:effectLst/>
       </p:bgPr>
@@ -3438,7 +3493,7 @@
             <a:pPr>
               <a:defRPr b="1" sz="3600">
                 <a:solidFill>
-                  <a:srgbClr val="FF4B4B"/>
+                  <a:srgbClr val="1E3C72"/>
                 </a:solidFill>
               </a:defRPr>
             </a:pPr>
@@ -3450,123 +3505,20 @@
       </p:sp>
       <p:sp>
         <p:nvSpPr>
-          <p:cNvPr id="3" name="Content Placeholder 2"/>
-          <p:cNvSpPr>
-            <a:spLocks noGrp="1"/>
-          </p:cNvSpPr>
-          <p:nvPr>
-            <p:ph idx="1"/>
-          </p:nvPr>
-        </p:nvSpPr>
-        <p:spPr/>
-        <p:txBody>
-          <a:bodyPr/>
-          <a:lstStyle/>
-          <a:p>
-            <a:pPr>
-              <a:spcAft>
-                <a:spcPts val="1400"/>
-              </a:spcAft>
-              <a:defRPr sz="2200">
-                <a:solidFill>
-                  <a:srgbClr val="E6E6E6"/>
-                </a:solidFill>
-              </a:defRPr>
-            </a:pPr>
-            <a:r>
-              <a:t>We modeled the logistics network not as isolated trips, but as a living Directed Graph to find structural flaws.</a:t>
-            </a:r>
-          </a:p>
-          <a:p>
-            <a:pPr>
-              <a:spcAft>
-                <a:spcPts val="1400"/>
-              </a:spcAft>
-              <a:defRPr sz="2200">
-                <a:solidFill>
-                  <a:srgbClr val="E6E6E6"/>
-                </a:solidFill>
-              </a:defRPr>
-            </a:pPr>
-          </a:p>
-          <a:p>
-            <a:pPr>
-              <a:spcAft>
-                <a:spcPts val="1400"/>
-              </a:spcAft>
-              <a:defRPr sz="2200">
-                <a:solidFill>
-                  <a:srgbClr val="E6E6E6"/>
-                </a:solidFill>
-              </a:defRPr>
-            </a:pPr>
-            <a:r>
-              <a:t>Network Scale:</a:t>
-            </a:r>
-          </a:p>
-          <a:p>
-            <a:pPr>
-              <a:spcAft>
-                <a:spcPts val="1400"/>
-              </a:spcAft>
-              <a:defRPr sz="2200">
-                <a:solidFill>
-                  <a:srgbClr val="E6E6E6"/>
-                </a:solidFill>
-              </a:defRPr>
-            </a:pPr>
-            <a:r>
-              <a:t>• 1,657 Connected Facilities (Nodes)</a:t>
-            </a:r>
-          </a:p>
-          <a:p>
-            <a:pPr>
-              <a:spcAft>
-                <a:spcPts val="1400"/>
-              </a:spcAft>
-              <a:defRPr sz="2200">
-                <a:solidFill>
-                  <a:srgbClr val="E6E6E6"/>
-                </a:solidFill>
-              </a:defRPr>
-            </a:pPr>
-            <a:r>
-              <a:t>• 2,783 Logistics Corridors (Edges)</a:t>
-            </a:r>
-          </a:p>
-          <a:p>
-            <a:pPr>
-              <a:spcAft>
-                <a:spcPts val="1400"/>
-              </a:spcAft>
-              <a:defRPr sz="2200">
-                <a:solidFill>
-                  <a:srgbClr val="E6E6E6"/>
-                </a:solidFill>
-              </a:defRPr>
-            </a:pPr>
-            <a:r>
-              <a:t>• 2,617 Chronic Delay Corridors Identified</a:t>
-            </a:r>
-          </a:p>
-        </p:txBody>
-      </p:sp>
-      <p:sp>
-        <p:nvSpPr>
-          <p:cNvPr id="4" name="Rectangle 3"/>
+          <p:cNvPr id="3" name="Rectangle 2"/>
           <p:cNvSpPr/>
           <p:nvPr/>
         </p:nvSpPr>
         <p:spPr>
           <a:xfrm>
             <a:off x="0" y="0"/>
-            <a:ext cx="9144000" cy="137160"/>
+            <a:ext cx="9144000" cy="182880"/>
           </a:xfrm>
           <a:prstGeom prst="rect">
             <a:avLst/>
           </a:prstGeom>
           <a:solidFill>
-            <a:srgbClr val="FF4B4B"/>
+            <a:srgbClr val="1E3C72"/>
           </a:solidFill>
           <a:ln>
             <a:noFill/>
@@ -3594,6 +3546,140 @@
           </a:p>
         </p:txBody>
       </p:sp>
+      <p:sp>
+        <p:nvSpPr>
+          <p:cNvPr id="4" name="TextBox 3"/>
+          <p:cNvSpPr txBox="1"/>
+          <p:nvPr/>
+        </p:nvSpPr>
+        <p:spPr>
+          <a:xfrm>
+            <a:off x="457200" y="1371600"/>
+            <a:ext cx="4572000" cy="3657600"/>
+          </a:xfrm>
+          <a:prstGeom prst="rect">
+            <a:avLst/>
+          </a:prstGeom>
+          <a:noFill/>
+        </p:spPr>
+        <p:txBody>
+          <a:bodyPr wrap="none">
+            <a:spAutoFit/>
+          </a:bodyPr>
+          <a:lstStyle/>
+          <a:p>
+            <a:pPr>
+              <a:spcAft>
+                <a:spcPts val="1200"/>
+              </a:spcAft>
+              <a:defRPr sz="2000">
+                <a:solidFill>
+                  <a:srgbClr val="282D32"/>
+                </a:solidFill>
+              </a:defRPr>
+            </a:pPr>
+            <a:r>
+              <a:t>We modeled the logistics network not as isolated trips, but as a living Directed Graph to find structural flaws.</a:t>
+            </a:r>
+          </a:p>
+          <a:p>
+            <a:pPr>
+              <a:spcAft>
+                <a:spcPts val="1200"/>
+              </a:spcAft>
+              <a:defRPr sz="2000">
+                <a:solidFill>
+                  <a:srgbClr val="282D32"/>
+                </a:solidFill>
+              </a:defRPr>
+            </a:pPr>
+          </a:p>
+          <a:p>
+            <a:pPr>
+              <a:spcAft>
+                <a:spcPts val="1200"/>
+              </a:spcAft>
+              <a:defRPr sz="2000">
+                <a:solidFill>
+                  <a:srgbClr val="282D32"/>
+                </a:solidFill>
+              </a:defRPr>
+            </a:pPr>
+            <a:r>
+              <a:t>Network Scale:</a:t>
+            </a:r>
+          </a:p>
+          <a:p>
+            <a:pPr>
+              <a:spcAft>
+                <a:spcPts val="1200"/>
+              </a:spcAft>
+              <a:defRPr sz="2000">
+                <a:solidFill>
+                  <a:srgbClr val="282D32"/>
+                </a:solidFill>
+              </a:defRPr>
+            </a:pPr>
+            <a:r>
+              <a:t>• 1,657 Connected Facilities (Nodes)</a:t>
+            </a:r>
+          </a:p>
+          <a:p>
+            <a:pPr>
+              <a:spcAft>
+                <a:spcPts val="1200"/>
+              </a:spcAft>
+              <a:defRPr sz="2000">
+                <a:solidFill>
+                  <a:srgbClr val="282D32"/>
+                </a:solidFill>
+              </a:defRPr>
+            </a:pPr>
+            <a:r>
+              <a:t>• 2,783 Logistics Corridors (Edges)</a:t>
+            </a:r>
+          </a:p>
+          <a:p>
+            <a:pPr>
+              <a:spcAft>
+                <a:spcPts val="1200"/>
+              </a:spcAft>
+              <a:defRPr sz="2000">
+                <a:solidFill>
+                  <a:srgbClr val="282D32"/>
+                </a:solidFill>
+              </a:defRPr>
+            </a:pPr>
+            <a:r>
+              <a:t>• 2,617 Chronic Delay Corridors Identified</a:t>
+            </a:r>
+          </a:p>
+        </p:txBody>
+      </p:sp>
+      <p:pic>
+        <p:nvPicPr>
+          <p:cNvPr id="5" name="Picture 4" descr="doodle_network.png"/>
+          <p:cNvPicPr>
+            <a:picLocks noChangeAspect="1"/>
+          </p:cNvPicPr>
+          <p:nvPr/>
+        </p:nvPicPr>
+        <p:blipFill>
+          <a:blip r:embed="rId2"/>
+          <a:stretch>
+            <a:fillRect/>
+          </a:stretch>
+        </p:blipFill>
+        <p:spPr>
+          <a:xfrm>
+            <a:off x="5029200" y="1371600"/>
+            <a:ext cx="3657600" cy="3657600"/>
+          </a:xfrm>
+          <a:prstGeom prst="rect">
+            <a:avLst/>
+          </a:prstGeom>
+        </p:spPr>
+      </p:pic>
     </p:spTree>
   </p:cSld>
   <p:clrMapOvr>
@@ -3608,7 +3694,7 @@
     <p:bg>
       <p:bgPr>
         <a:solidFill>
-          <a:srgbClr val="1E1E23"/>
+          <a:srgbClr val="F5F7FA"/>
         </a:solidFill>
         <a:effectLst/>
       </p:bgPr>
@@ -3638,7 +3724,7 @@
             <a:pPr>
               <a:defRPr b="1" sz="3600">
                 <a:solidFill>
-                  <a:srgbClr val="FF4B4B"/>
+                  <a:srgbClr val="1E3C72"/>
                 </a:solidFill>
               </a:defRPr>
             </a:pPr>
@@ -3657,13 +3743,13 @@
         <p:spPr>
           <a:xfrm>
             <a:off x="0" y="0"/>
-            <a:ext cx="9144000" cy="137160"/>
+            <a:ext cx="9144000" cy="182880"/>
           </a:xfrm>
           <a:prstGeom prst="rect">
             <a:avLst/>
           </a:prstGeom>
           <a:solidFill>
-            <a:srgbClr val="FF4B4B"/>
+            <a:srgbClr val="1E3C72"/>
           </a:solidFill>
           <a:ln>
             <a:noFill/>
@@ -3729,7 +3815,7 @@
     <p:bg>
       <p:bgPr>
         <a:solidFill>
-          <a:srgbClr val="1E1E23"/>
+          <a:srgbClr val="F5F7FA"/>
         </a:solidFill>
         <a:effectLst/>
       </p:bgPr>
@@ -3759,7 +3845,7 @@
             <a:pPr>
               <a:defRPr b="1" sz="3600">
                 <a:solidFill>
-                  <a:srgbClr val="FF4B4B"/>
+                  <a:srgbClr val="1E3C72"/>
                 </a:solidFill>
               </a:defRPr>
             </a:pPr>
@@ -3778,13 +3864,13 @@
         <p:spPr>
           <a:xfrm>
             <a:off x="0" y="0"/>
-            <a:ext cx="9144000" cy="137160"/>
+            <a:ext cx="9144000" cy="182880"/>
           </a:xfrm>
           <a:prstGeom prst="rect">
             <a:avLst/>
           </a:prstGeom>
           <a:solidFill>
-            <a:srgbClr val="FF4B4B"/>
+            <a:srgbClr val="1E3C72"/>
           </a:solidFill>
           <a:ln>
             <a:noFill/>
@@ -3850,7 +3936,7 @@
     <p:bg>
       <p:bgPr>
         <a:solidFill>
-          <a:srgbClr val="1E1E23"/>
+          <a:srgbClr val="F5F7FA"/>
         </a:solidFill>
         <a:effectLst/>
       </p:bgPr>
@@ -3880,7 +3966,7 @@
             <a:pPr>
               <a:defRPr b="1" sz="3600">
                 <a:solidFill>
-                  <a:srgbClr val="FF4B4B"/>
+                  <a:srgbClr val="1E3C72"/>
                 </a:solidFill>
               </a:defRPr>
             </a:pPr>
@@ -3899,13 +3985,13 @@
         <p:spPr>
           <a:xfrm>
             <a:off x="0" y="0"/>
-            <a:ext cx="9144000" cy="137160"/>
+            <a:ext cx="9144000" cy="182880"/>
           </a:xfrm>
           <a:prstGeom prst="rect">
             <a:avLst/>
           </a:prstGeom>
           <a:solidFill>
-            <a:srgbClr val="FF4B4B"/>
+            <a:srgbClr val="1E3C72"/>
           </a:solidFill>
           <a:ln>
             <a:noFill/>
@@ -3982,7 +4068,7 @@
             <a:pPr algn="ctr">
               <a:defRPr b="1" sz="2200">
                 <a:solidFill>
-                  <a:srgbClr val="4CAF50"/>
+                  <a:srgbClr val="28A745"/>
                 </a:solidFill>
               </a:defRPr>
             </a:pPr>
@@ -4006,7 +4092,7 @@
     <p:bg>
       <p:bgPr>
         <a:solidFill>
-          <a:srgbClr val="1E1E23"/>
+          <a:srgbClr val="F5F7FA"/>
         </a:solidFill>
         <a:effectLst/>
       </p:bgPr>
@@ -4036,7 +4122,7 @@
             <a:pPr>
               <a:defRPr b="1" sz="3600">
                 <a:solidFill>
-                  <a:srgbClr val="FF4B4B"/>
+                  <a:srgbClr val="1E3C72"/>
                 </a:solidFill>
               </a:defRPr>
             </a:pPr>
@@ -4055,13 +4141,13 @@
         <p:spPr>
           <a:xfrm>
             <a:off x="0" y="0"/>
-            <a:ext cx="9144000" cy="137160"/>
+            <a:ext cx="9144000" cy="182880"/>
           </a:xfrm>
           <a:prstGeom prst="rect">
             <a:avLst/>
           </a:prstGeom>
           <a:solidFill>
-            <a:srgbClr val="FF4B4B"/>
+            <a:srgbClr val="1E3C72"/>
           </a:solidFill>
           <a:ln>
             <a:noFill/>
@@ -4127,7 +4213,7 @@
     <p:bg>
       <p:bgPr>
         <a:solidFill>
-          <a:srgbClr val="1E1E23"/>
+          <a:srgbClr val="F5F7FA"/>
         </a:solidFill>
         <a:effectLst/>
       </p:bgPr>
@@ -4157,7 +4243,7 @@
             <a:pPr>
               <a:defRPr b="1" sz="3600">
                 <a:solidFill>
-                  <a:srgbClr val="FF4B4B"/>
+                  <a:srgbClr val="1E3C72"/>
                 </a:solidFill>
               </a:defRPr>
             </a:pPr>
@@ -4184,11 +4270,11 @@
           <a:p>
             <a:pPr>
               <a:spcAft>
-                <a:spcPts val="1400"/>
+                <a:spcPts val="1200"/>
               </a:spcAft>
-              <a:defRPr sz="2200">
+              <a:defRPr sz="2000">
                 <a:solidFill>
-                  <a:srgbClr val="E6E6E6"/>
+                  <a:srgbClr val="282D32"/>
                 </a:solidFill>
               </a:defRPr>
             </a:pPr>
@@ -4199,11 +4285,11 @@
           <a:p>
             <a:pPr>
               <a:spcAft>
-                <a:spcPts val="1400"/>
+                <a:spcPts val="1200"/>
               </a:spcAft>
-              <a:defRPr sz="2200">
+              <a:defRPr sz="2000">
                 <a:solidFill>
-                  <a:srgbClr val="E6E6E6"/>
+                  <a:srgbClr val="282D32"/>
                 </a:solidFill>
               </a:defRPr>
             </a:pPr>
@@ -4214,11 +4300,11 @@
           <a:p>
             <a:pPr>
               <a:spcAft>
-                <a:spcPts val="1400"/>
+                <a:spcPts val="1200"/>
               </a:spcAft>
-              <a:defRPr sz="2200">
+              <a:defRPr sz="2000">
                 <a:solidFill>
-                  <a:srgbClr val="E6E6E6"/>
+                  <a:srgbClr val="282D32"/>
                 </a:solidFill>
               </a:defRPr>
             </a:pPr>
@@ -4237,13 +4323,13 @@
         <p:spPr>
           <a:xfrm>
             <a:off x="0" y="0"/>
-            <a:ext cx="9144000" cy="137160"/>
+            <a:ext cx="9144000" cy="182880"/>
           </a:xfrm>
           <a:prstGeom prst="rect">
             <a:avLst/>
           </a:prstGeom>
           <a:solidFill>
-            <a:srgbClr val="FF4B4B"/>
+            <a:srgbClr val="1E3C72"/>
           </a:solidFill>
           <a:ln>
             <a:noFill/>
@@ -4285,7 +4371,7 @@
     <p:bg>
       <p:bgPr>
         <a:solidFill>
-          <a:srgbClr val="1E1E23"/>
+          <a:srgbClr val="F5F7FA"/>
         </a:solidFill>
         <a:effectLst/>
       </p:bgPr>
@@ -4315,7 +4401,7 @@
             <a:pPr>
               <a:defRPr sz="5400">
                 <a:solidFill>
-                  <a:srgbClr val="FF4B4B"/>
+                  <a:srgbClr val="1E3C72"/>
                 </a:solidFill>
               </a:defRPr>
             </a:pPr>
@@ -4343,7 +4429,7 @@
             <a:pPr>
               <a:defRPr sz="2400">
                 <a:solidFill>
-                  <a:srgbClr val="E6E6E6"/>
+                  <a:srgbClr val="282D32"/>
                 </a:solidFill>
               </a:defRPr>
             </a:pPr>
@@ -4367,13 +4453,13 @@
         <p:spPr>
           <a:xfrm>
             <a:off x="0" y="0"/>
-            <a:ext cx="9144000" cy="137160"/>
+            <a:ext cx="9144000" cy="182880"/>
           </a:xfrm>
           <a:prstGeom prst="rect">
             <a:avLst/>
           </a:prstGeom>
           <a:solidFill>
-            <a:srgbClr val="FF4B4B"/>
+            <a:srgbClr val="1E3C72"/>
           </a:solidFill>
           <a:ln>
             <a:noFill/>

</xml_diff>

<commit_message>
Fix truck doodle position on PPTX title slide
</commit_message>
<xml_diff>
--- a/Pitch_Deck.pptx
+++ b/Pitch_Deck.pptx
@@ -3225,8 +3225,8 @@
         </p:blipFill>
         <p:spPr>
           <a:xfrm>
-            <a:off x="3200400" y="4114800"/>
-            <a:ext cx="2286000" cy="2286000"/>
+            <a:off x="3657600" y="4754880"/>
+            <a:ext cx="1645920" cy="1645920"/>
           </a:xfrm>
           <a:prstGeom prst="rect">
             <a:avLst/>

</xml_diff>

<commit_message>
Cleanup: Remove generator scripts and HTML reports; fix PPTX layout
</commit_message>
<xml_diff>
--- a/Pitch_Deck.pptx
+++ b/Pitch_Deck.pptx
@@ -3225,8 +3225,8 @@
         </p:blipFill>
         <p:spPr>
           <a:xfrm>
-            <a:off x="3657600" y="4754880"/>
-            <a:ext cx="1645920" cy="1645920"/>
+            <a:off x="6858000" y="5029200"/>
+            <a:ext cx="1371600" cy="1371600"/>
           </a:xfrm>
           <a:prstGeom prst="rect">
             <a:avLst/>

</xml_diff>